<commit_message>
Snapshot current project state on Agent branch
Aligns the Agent branch with the current local working copy: updated
ScriptsAndTools code (ImportOrModifyPoints, Helpers, QA), adds
Configs.example.py and a .gitignore, and removes stale ArcGIS/Task
artifacts no longer present locally.

Co-Authored-By: Claude Opus 4.8 (1M context) <noreply@anthropic.com>
</commit_message>
<xml_diff>
--- a/docs/Configurations.pptx
+++ b/docs/Configurations.pptx
@@ -261,7 +261,7 @@
           <a:p>
             <a:fld id="{658F0C34-3836-40F8-B3C6-F9712816DBA1}" type="datetimeFigureOut">
               <a:rPr lang="he-IL" smtClean="0"/>
-              <a:t>י"ז/כסלו/תשפ"ו</a:t>
+              <a:t>ה'/אלול/תשפ"ו</a:t>
             </a:fld>
             <a:endParaRPr lang="he-IL"/>
           </a:p>
@@ -461,7 +461,7 @@
           <a:p>
             <a:fld id="{658F0C34-3836-40F8-B3C6-F9712816DBA1}" type="datetimeFigureOut">
               <a:rPr lang="he-IL" smtClean="0"/>
-              <a:t>י"ז/כסלו/תשפ"ו</a:t>
+              <a:t>ה'/אלול/תשפ"ו</a:t>
             </a:fld>
             <a:endParaRPr lang="he-IL"/>
           </a:p>
@@ -671,7 +671,7 @@
           <a:p>
             <a:fld id="{658F0C34-3836-40F8-B3C6-F9712816DBA1}" type="datetimeFigureOut">
               <a:rPr lang="he-IL" smtClean="0"/>
-              <a:t>י"ז/כסלו/תשפ"ו</a:t>
+              <a:t>ה'/אלול/תשפ"ו</a:t>
             </a:fld>
             <a:endParaRPr lang="he-IL"/>
           </a:p>
@@ -871,7 +871,7 @@
           <a:p>
             <a:fld id="{658F0C34-3836-40F8-B3C6-F9712816DBA1}" type="datetimeFigureOut">
               <a:rPr lang="he-IL" smtClean="0"/>
-              <a:t>י"ז/כסלו/תשפ"ו</a:t>
+              <a:t>ה'/אלול/תשפ"ו</a:t>
             </a:fld>
             <a:endParaRPr lang="he-IL"/>
           </a:p>
@@ -1147,7 +1147,7 @@
           <a:p>
             <a:fld id="{658F0C34-3836-40F8-B3C6-F9712816DBA1}" type="datetimeFigureOut">
               <a:rPr lang="he-IL" smtClean="0"/>
-              <a:t>י"ז/כסלו/תשפ"ו</a:t>
+              <a:t>ה'/אלול/תשפ"ו</a:t>
             </a:fld>
             <a:endParaRPr lang="he-IL"/>
           </a:p>
@@ -1415,7 +1415,7 @@
           <a:p>
             <a:fld id="{658F0C34-3836-40F8-B3C6-F9712816DBA1}" type="datetimeFigureOut">
               <a:rPr lang="he-IL" smtClean="0"/>
-              <a:t>י"ז/כסלו/תשפ"ו</a:t>
+              <a:t>ה'/אלול/תשפ"ו</a:t>
             </a:fld>
             <a:endParaRPr lang="he-IL"/>
           </a:p>
@@ -1830,7 +1830,7 @@
           <a:p>
             <a:fld id="{658F0C34-3836-40F8-B3C6-F9712816DBA1}" type="datetimeFigureOut">
               <a:rPr lang="he-IL" smtClean="0"/>
-              <a:t>י"ז/כסלו/תשפ"ו</a:t>
+              <a:t>ה'/אלול/תשפ"ו</a:t>
             </a:fld>
             <a:endParaRPr lang="he-IL"/>
           </a:p>
@@ -1972,7 +1972,7 @@
           <a:p>
             <a:fld id="{658F0C34-3836-40F8-B3C6-F9712816DBA1}" type="datetimeFigureOut">
               <a:rPr lang="he-IL" smtClean="0"/>
-              <a:t>י"ז/כסלו/תשפ"ו</a:t>
+              <a:t>ה'/אלול/תשפ"ו</a:t>
             </a:fld>
             <a:endParaRPr lang="he-IL"/>
           </a:p>
@@ -2085,7 +2085,7 @@
           <a:p>
             <a:fld id="{658F0C34-3836-40F8-B3C6-F9712816DBA1}" type="datetimeFigureOut">
               <a:rPr lang="he-IL" smtClean="0"/>
-              <a:t>י"ז/כסלו/תשפ"ו</a:t>
+              <a:t>ה'/אלול/תשפ"ו</a:t>
             </a:fld>
             <a:endParaRPr lang="he-IL"/>
           </a:p>
@@ -2398,7 +2398,7 @@
           <a:p>
             <a:fld id="{658F0C34-3836-40F8-B3C6-F9712816DBA1}" type="datetimeFigureOut">
               <a:rPr lang="he-IL" smtClean="0"/>
-              <a:t>י"ז/כסלו/תשפ"ו</a:t>
+              <a:t>ה'/אלול/תשפ"ו</a:t>
             </a:fld>
             <a:endParaRPr lang="he-IL"/>
           </a:p>
@@ -2687,7 +2687,7 @@
           <a:p>
             <a:fld id="{658F0C34-3836-40F8-B3C6-F9712816DBA1}" type="datetimeFigureOut">
               <a:rPr lang="he-IL" smtClean="0"/>
-              <a:t>י"ז/כסלו/תשפ"ו</a:t>
+              <a:t>ה'/אלול/תשפ"ו</a:t>
             </a:fld>
             <a:endParaRPr lang="he-IL"/>
           </a:p>
@@ -2930,7 +2930,7 @@
           <a:p>
             <a:fld id="{658F0C34-3836-40F8-B3C6-F9712816DBA1}" type="datetimeFigureOut">
               <a:rPr lang="he-IL" smtClean="0"/>
-              <a:t>י"ז/כסלו/תשפ"ו</a:t>
+              <a:t>ה'/אלול/תשפ"ו</a:t>
             </a:fld>
             <a:endParaRPr lang="he-IL"/>
           </a:p>
@@ -3428,17 +3428,19 @@
           <p:cNvCxnSpPr>
             <a:cxnSpLocks/>
             <a:stCxn id="18" idx="2"/>
-            <a:endCxn id="46" idx="1"/>
+            <a:endCxn id="5" idx="0"/>
           </p:cNvCxnSpPr>
           <p:nvPr/>
         </p:nvCxnSpPr>
         <p:spPr>
           <a:xfrm rot="16200000" flipH="1">
-            <a:off x="1657336" y="1224180"/>
-            <a:ext cx="1138611" cy="1424214"/>
+            <a:off x="2134648" y="746868"/>
+            <a:ext cx="802782" cy="2043010"/>
           </a:xfrm>
-          <a:prstGeom prst="curvedConnector2">
-            <a:avLst/>
+          <a:prstGeom prst="curvedConnector3">
+            <a:avLst>
+              <a:gd name="adj1" fmla="val 50000"/>
+            </a:avLst>
           </a:prstGeom>
           <a:ln w="28575">
             <a:solidFill>
@@ -3477,7 +3479,7 @@
         </p:nvSpPr>
         <p:spPr>
           <a:xfrm>
-            <a:off x="1193273" y="6157576"/>
+            <a:off x="3069433" y="6137101"/>
             <a:ext cx="976221" cy="287549"/>
           </a:xfrm>
           <a:prstGeom prst="roundRect">
@@ -3535,20 +3537,18 @@
           </p:cNvPr>
           <p:cNvCxnSpPr>
             <a:cxnSpLocks/>
-            <a:stCxn id="34" idx="0"/>
-            <a:endCxn id="1100" idx="2"/>
+            <a:stCxn id="34" idx="1"/>
+            <a:endCxn id="1102" idx="2"/>
           </p:cNvCxnSpPr>
           <p:nvPr/>
         </p:nvCxnSpPr>
         <p:spPr>
-          <a:xfrm rot="16200000" flipV="1">
-            <a:off x="886506" y="5362697"/>
-            <a:ext cx="1430907" cy="158851"/>
+          <a:xfrm rot="10800000">
+            <a:off x="1793841" y="5059622"/>
+            <a:ext cx="1275593" cy="1221255"/>
           </a:xfrm>
-          <a:prstGeom prst="curvedConnector3">
-            <a:avLst>
-              <a:gd name="adj1" fmla="val 50000"/>
-            </a:avLst>
+          <a:prstGeom prst="curvedConnector2">
+            <a:avLst/>
           </a:prstGeom>
           <a:ln w="28575">
             <a:solidFill>
@@ -3587,7 +3587,7 @@
         </p:nvGrpSpPr>
         <p:grpSpPr>
           <a:xfrm>
-            <a:off x="2938748" y="2169764"/>
+            <a:off x="1962874" y="2169764"/>
             <a:ext cx="3189337" cy="671657"/>
             <a:chOff x="2584929" y="3170797"/>
             <a:chExt cx="6183602" cy="1778838"/>
@@ -3659,8 +3659,8 @@
           </p:nvSpPr>
           <p:spPr>
             <a:xfrm>
-              <a:off x="2584934" y="3170797"/>
-              <a:ext cx="6183597" cy="374659"/>
+              <a:off x="2584935" y="3170797"/>
+              <a:ext cx="6183596" cy="374658"/>
             </a:xfrm>
             <a:prstGeom prst="roundRect">
               <a:avLst/>
@@ -3977,8 +3977,8 @@
         </p:nvCxnSpPr>
         <p:spPr>
           <a:xfrm rot="5400000">
-            <a:off x="4830123" y="1070278"/>
-            <a:ext cx="802782" cy="1396191"/>
+            <a:off x="4342186" y="582341"/>
+            <a:ext cx="802782" cy="2372065"/>
           </a:xfrm>
           <a:prstGeom prst="curvedConnector3">
             <a:avLst/>
@@ -5374,13 +5374,13 @@
           <p:nvPr>
             <p:extLst>
               <p:ext uri="{D42A27DB-BD31-4B8C-83A1-F6EECF244321}">
-                <p14:modId xmlns:p14="http://schemas.microsoft.com/office/powerpoint/2010/main" val="1852510666"/>
+                <p14:modId xmlns:p14="http://schemas.microsoft.com/office/powerpoint/2010/main" val="103054444"/>
               </p:ext>
             </p:extLst>
           </p:nvPr>
         </p:nvGraphicFramePr>
         <p:xfrm>
-          <a:off x="2989070" y="2429279"/>
+          <a:off x="2013196" y="2461195"/>
           <a:ext cx="3088697" cy="274320"/>
         </p:xfrm>
         <a:graphic>
@@ -5569,18 +5569,20 @@
           </p:cNvPr>
           <p:cNvCxnSpPr>
             <a:cxnSpLocks/>
-            <a:stCxn id="46" idx="1"/>
+            <a:stCxn id="46" idx="2"/>
             <a:endCxn id="1101" idx="0"/>
           </p:cNvCxnSpPr>
           <p:nvPr/>
         </p:nvCxnSpPr>
         <p:spPr>
-          <a:xfrm rot="10800000" flipV="1">
-            <a:off x="1522534" y="2505593"/>
-            <a:ext cx="1416215" cy="884178"/>
+          <a:xfrm rot="5400000">
+            <a:off x="2195527" y="2439736"/>
+            <a:ext cx="960330" cy="1763700"/>
           </a:xfrm>
-          <a:prstGeom prst="curvedConnector2">
-            <a:avLst/>
+          <a:prstGeom prst="curvedConnector3">
+            <a:avLst>
+              <a:gd name="adj1" fmla="val 50000"/>
+            </a:avLst>
           </a:prstGeom>
           <a:ln w="28575">
             <a:solidFill>
@@ -5619,7 +5621,7 @@
         </p:nvGrpSpPr>
         <p:grpSpPr>
           <a:xfrm>
-            <a:off x="393496" y="3389771"/>
+            <a:off x="664805" y="3801751"/>
             <a:ext cx="2258073" cy="1336898"/>
             <a:chOff x="309115" y="932371"/>
             <a:chExt cx="1751162" cy="1663047"/>
@@ -5740,13 +5742,13 @@
           <p:nvPr>
             <p:extLst>
               <p:ext uri="{D42A27DB-BD31-4B8C-83A1-F6EECF244321}">
-                <p14:modId xmlns:p14="http://schemas.microsoft.com/office/powerpoint/2010/main" val="1482891051"/>
+                <p14:modId xmlns:p14="http://schemas.microsoft.com/office/powerpoint/2010/main" val="2771703804"/>
               </p:ext>
             </p:extLst>
           </p:nvPr>
         </p:nvGraphicFramePr>
         <p:xfrm>
-          <a:off x="475815" y="3824681"/>
+          <a:off x="747124" y="4236661"/>
           <a:ext cx="2093433" cy="822960"/>
         </p:xfrm>
         <a:graphic>
@@ -6875,8 +6877,8 @@
         </p:nvCxnSpPr>
         <p:spPr>
           <a:xfrm rot="16200000" flipH="1">
-            <a:off x="4291154" y="3083682"/>
-            <a:ext cx="1103319" cy="618795"/>
+            <a:off x="3803217" y="2595745"/>
+            <a:ext cx="1103319" cy="1594669"/>
           </a:xfrm>
           <a:prstGeom prst="curvedConnector3">
             <a:avLst>
@@ -6918,19 +6920,17 @@
           <p:cNvCxnSpPr>
             <a:cxnSpLocks/>
             <a:stCxn id="34" idx="3"/>
-            <a:endCxn id="1127" idx="1"/>
+            <a:endCxn id="1127" idx="2"/>
           </p:cNvCxnSpPr>
           <p:nvPr/>
         </p:nvCxnSpPr>
         <p:spPr>
           <a:xfrm flipV="1">
-            <a:off x="2169494" y="4613189"/>
-            <a:ext cx="2057161" cy="1688162"/>
+            <a:off x="4045654" y="5281638"/>
+            <a:ext cx="1106557" cy="999238"/>
           </a:xfrm>
-          <a:prstGeom prst="curvedConnector3">
-            <a:avLst>
-              <a:gd name="adj1" fmla="val 50000"/>
-            </a:avLst>
+          <a:prstGeom prst="curvedConnector2">
+            <a:avLst/>
           </a:prstGeom>
           <a:ln w="28575">
             <a:solidFill>

</xml_diff>